<commit_message>
slides NOSCAM bleus, consigne generique, sans mention video
</commit_message>
<xml_diff>
--- a/NOSCAM_PITCH.pptx
+++ b/NOSCAM_PITCH.pptx
@@ -3088,7 +3088,7 @@
     <p:bg>
       <p:bgPr>
         <a:solidFill>
-          <a:srgbClr val="0B7A55"/>
+          <a:srgbClr val="1D4ED8"/>
         </a:solidFill>
         <a:effectLst/>
       </p:bgPr>
@@ -3200,7 +3200,7 @@
               </a:defRPr>
             </a:pPr>
             <a:r>
-              <a:t>Collez un SMS Flooz / TMoney → ARNAQUE ou NORMAL + score. Modèle local, offline, reproductible.</a:t>
+              <a:t>Collez un SMS → ARNAQUE ou NORMAL + score. Modèle local, offline, reproductible.</a:t>
             </a:r>
           </a:p>
         </p:txBody>
@@ -3235,7 +3235,7 @@
               </a:defRPr>
             </a:pPr>
             <a:r>
-              <a:t>github.com/yakuzas2345/ai4youth  •  Cybersécurité  •  Vidéo 2 min ce soir</a:t>
+              <a:t>github.com/yakuzas2345/ai4youth  •  Cybersécurité</a:t>
             </a:r>
           </a:p>
         </p:txBody>
@@ -3283,7 +3283,7 @@
             <a:pPr algn="l">
               <a:defRPr sz="3600" b="1">
                 <a:solidFill>
-                  <a:srgbClr val="0B7A55"/>
+                  <a:srgbClr val="1D4ED8"/>
                 </a:solidFill>
               </a:defRPr>
             </a:pPr>
@@ -3341,7 +3341,7 @@
               </a:defRPr>
             </a:pPr>
             <a:r>
-              <a:t>• Faux SMS quotidiens : « Flooz bloqué, cliquez », « envoie ton PIN », « c'est ton oncle »</a:t>
+              <a:t>• Faux SMS quotidiens : compte bloqué, envoie ton PIN, c'est ton oncle</a:t>
             </a:r>
           </a:p>
           <a:p>
@@ -3424,7 +3424,7 @@
               </a:defRPr>
             </a:pPr>
             <a:r>
-              <a:t>• Ex SCAM : « Vous avez reçu 50000 FCFA, envoyez PIN »</a:t>
+              <a:t>• Ex ARNAQUE : vous avez reçu 50000, envoyez PIN</a:t>
             </a:r>
           </a:p>
           <a:p>
@@ -3439,7 +3439,7 @@
               </a:defRPr>
             </a:pPr>
             <a:r>
-              <a:t>• Ex SCAM : « Compte Flooz bloqué, cliquez »</a:t>
+              <a:t>• Ex ARNAQUE : compte bloqué, cliquez</a:t>
             </a:r>
           </a:p>
           <a:p>
@@ -3454,7 +3454,7 @@
               </a:defRPr>
             </a:pPr>
             <a:r>
-              <a:t>• Ex NORMAL : « On se voit au marché demain ? »</a:t>
+              <a:t>• Ex NORMAL : on se voit au marché demain ?</a:t>
             </a:r>
           </a:p>
           <a:p>
@@ -3517,7 +3517,7 @@
             <a:pPr algn="l">
               <a:defRPr sz="3600" b="1">
                 <a:solidFill>
-                  <a:srgbClr val="0B7A55"/>
+                  <a:srgbClr val="1D4ED8"/>
                 </a:solidFill>
               </a:defRPr>
             </a:pPr>
@@ -3575,7 +3575,7 @@
               </a:defRPr>
             </a:pPr>
             <a:r>
-              <a:t>• Usage : colle SMS → Analyser → 🚨 ARNAQUE 95% / ✅ NORMAL</a:t>
+              <a:t>• Usage : collez un SMS → Analyser → résultat + conseil</a:t>
             </a:r>
           </a:p>
           <a:p>
@@ -3673,7 +3673,7 @@
               </a:defRPr>
             </a:pPr>
             <a:r>
-              <a:t>• Entraîné sur 5600 SMS (UCI + 30 Togo x10)</a:t>
+              <a:t>• Entraîné sur 5600 SMS</a:t>
             </a:r>
           </a:p>
           <a:p>
@@ -3736,7 +3736,7 @@
             <a:pPr algn="l">
               <a:defRPr sz="3600" b="1">
                 <a:solidFill>
-                  <a:srgbClr val="0B7A55"/>
+                  <a:srgbClr val="1D4ED8"/>
                 </a:solidFill>
               </a:defRPr>
             </a:pPr>
@@ -3794,7 +3794,7 @@
               </a:defRPr>
             </a:pPr>
             <a:r>
-              <a:t>• LogReg F1-spam 0,87 vs XGBoost 0,92 (val) → XGBoost retenu</a:t>
+              <a:t>• LogReg F1 0,87 vs XGBoost 0,92 (val) → XGBoost retenu</a:t>
             </a:r>
           </a:p>
           <a:p>
@@ -3809,7 +3809,7 @@
               </a:defRPr>
             </a:pPr>
             <a:r>
-              <a:t>• TEST : accuracy 0,98, F1-spam 0,94, ROC-AUC 0,985</a:t>
+              <a:t>• TEST : accuracy 0,98, F1 0,94, ROC-AUC 0,985</a:t>
             </a:r>
           </a:p>
           <a:p>
@@ -3824,7 +3824,7 @@
               </a:defRPr>
             </a:pPr>
             <a:r>
-              <a:t>• Démo Togo : SCAM Flooz 100% / NORMAL marché 1%</a:t>
+              <a:t>• Démo : ARNAQUE 100% / NORMAL 1%</a:t>
             </a:r>
           </a:p>
           <a:p>
@@ -3911,7 +3911,7 @@
             <a:pPr algn="l">
               <a:defRPr sz="3200" b="1">
                 <a:solidFill>
-                  <a:srgbClr val="0B7A55"/>
+                  <a:srgbClr val="1D4ED8"/>
                 </a:solidFill>
               </a:defRPr>
             </a:pPr>
@@ -4014,7 +4014,7 @@
               </a:defRPr>
             </a:pPr>
             <a:r>
-              <a:t>• Limites avouées : 30 Togo aujourd'hui, pas d'Ewe oral</a:t>
+              <a:t>• Limites avouées : 30 exemples locaux aujourd'hui, pas d'oral</a:t>
             </a:r>
           </a:p>
         </p:txBody>

</xml_diff>